<commit_message>
Fix retest, answer-key, probe and decay logic; theme Insights; add open-set scores; clean up config
</commit_message>
<xml_diff>
--- a/docs/deck/ReLearn_pitch.pptx
+++ b/docs/deck/ReLearn_pitch.pptx
@@ -119,25 +119,25 @@
   <p:extLst>
     <p:ext uri="{521415D9-36F7-43E2-AB2F-B90AF26B5E84}">
       <p14:sectionLst xmlns:p14="http://schemas.microsoft.com/office/powerpoint/2010/main">
-        <p14:section name="Opening" id="{ddd557f8-3490-318b-fc3d-4ea848d320bd}">
+        <p14:section name="Opening" id="{46755a0d-dbe2-92d5-ec38-f1ebfa756dee}">
           <p14:sldIdLst>
             <p14:sldId id="256"/>
           </p14:sldIdLst>
         </p14:section>
-        <p14:section name="Problem and solution" id="{350ec5e7-e894-5922-791b-8ece54054202}">
+        <p14:section name="Problem and solution" id="{e0ec0ce2-2763-2f12-77f1-754c50fe035f}">
           <p14:sldIdLst>
             <p14:sldId id="257"/>
             <p14:sldId id="258"/>
             <p14:sldId id="259"/>
           </p14:sldIdLst>
         </p14:section>
-        <p14:section name="System" id="{3697dab0-5340-24bb-26ed-c255ef44bfea}">
+        <p14:section name="System" id="{36797da8-b93f-b46f-bd47-34a9d62fcf0c}">
           <p14:sldIdLst>
             <p14:sldId id="260"/>
             <p14:sldId id="261"/>
           </p14:sldIdLst>
         </p14:section>
-        <p14:section name="Results" id="{1b347de3-2859-72e7-c17a-354d9e25aa32}">
+        <p14:section name="Results" id="{c8681891-0f3c-58cc-4704-92729cb57643}">
           <p14:sldIdLst>
             <p14:sldId id="262"/>
             <p14:sldId id="263"/>
@@ -146,7 +146,7 @@
             <p14:sldId id="266"/>
           </p14:sldIdLst>
         </p14:section>
-        <p14:section name="Close" id="{fd2337e4-e8fe-32aa-7388-8e3f6f61db5b}">
+        <p14:section name="Close" id="{dc01c3a5-2743-3643-0985-f1316f4621d6}">
           <p14:sldIdLst>
             <p14:sldId id="267"/>
             <p14:sldId id="268"/>
@@ -636,10 +636,10 @@
                   <c:v>0.628125</c:v>
                 </c:pt>
                 <c:pt idx="1">
-                  <c:v>0.83125</c:v>
+                  <c:v>0.8325</c:v>
                 </c:pt>
                 <c:pt idx="2">
-                  <c:v>0.875625</c:v>
+                  <c:v>0.87375</c:v>
                 </c:pt>
               </c:numCache>
             </c:numRef>
@@ -719,10 +719,10 @@
                   <c:v>0.7259615384615384</c:v>
                 </c:pt>
                 <c:pt idx="1">
-                  <c:v>0.8552884615384615</c:v>
+                  <c:v>0.8567307692307692</c:v>
                 </c:pt>
                 <c:pt idx="2">
-                  <c:v>0.8860576923076923</c:v>
+                  <c:v>0.8798076923076923</c:v>
                 </c:pt>
               </c:numCache>
             </c:numRef>
@@ -2855,7 +2855,7 @@
           <a:p>
             <a:r>
               <a:rPr lang="en-US" dirty="0"/>
-              <a:t>Information gain beats a random relevant probe in all four settings we tested. The student just sees a short 'Quick check' question; the uncertainty maths stays in Insights.</a:t>
+              <a:t>Information gain beats a random relevant probe in three of the four settings; on baseline validation it is level with random (0.965 vs 0.967). The student just sees a short 'Quick check' question; the uncertainty maths stays in Insights.</a:t>
             </a:r>
             <a:endParaRPr lang="en-US" dirty="0"/>
           </a:p>
@@ -9917,7 +9917,7 @@
                   <a:schemeClr val="accent3"/>
                 </a:solidFill>
               </a:rPr>
-              <a:t>+16 pts</a:t>
+              <a:t>+15 pts</a:t>
             </a:r>
             <a:endParaRPr lang="en-US" sz="1500" dirty="0"/>
           </a:p>

</xml_diff>